<commit_message>
Dan Mayer Law: change proposal to Fractional CTO Level 1 only ($3,797/mo stand-alone); remove AI Workforce Pro from report, PPTX, Sales Companion, package_decision (seller request via Slack)
</commit_message>
<xml_diff>
--- a/dan-mayer-law/Dan_Mayer_Law_October_29_2026_Proposal.pptx
+++ b/dan-mayer-law/Dan_Mayer_Law_October_29_2026_Proposal.pptx
@@ -4599,7 +4599,7 @@
                 </a:solidFill>
                 <a:latin typeface="Poppins"/>
               </a:rPr>
-              <a:t>Growth means added payroll unless AI staff take on the repeatable work</a:t>
+              <a:t>Growth means added payroll unless AI takes on the repeatable work</a:t>
             </a:r>
           </a:p>
         </p:txBody>
@@ -5671,7 +5671,7 @@
                 </a:solidFill>
                 <a:latin typeface="Poppins"/>
               </a:rPr>
-              <a:t>Add AI Staff,</a:t>
+              <a:t>Add Capacity,</a:t>
             </a:r>
           </a:p>
         </p:txBody>
@@ -5792,7 +5792,7 @@
                 </a:solidFill>
                 <a:latin typeface="Poppins"/>
               </a:rPr>
-              <a:t>AI Workforce Pro seats for 10 users</a:t>
+              <a:t>Skills deployed from the AI library each month</a:t>
             </a:r>
           </a:p>
           <a:p>
@@ -5813,7 +5813,7 @@
                 </a:solidFill>
                 <a:latin typeface="Poppins"/>
               </a:rPr>
-              <a:t>A managed workspace for client work</a:t>
+              <a:t>A custom automation built every month</a:t>
             </a:r>
           </a:p>
           <a:p>
@@ -5834,7 +5834,7 @@
                 </a:solidFill>
                 <a:latin typeface="Poppins"/>
               </a:rPr>
-              <a:t>Weekly implementation session with our team</a:t>
+              <a:t>Training videos on skills and automations</a:t>
             </a:r>
           </a:p>
           <a:p>
@@ -6353,7 +6353,7 @@
                 </a:solidFill>
                 <a:latin typeface="Poppins"/>
               </a:rPr>
-              <a:t>$3,297</a:t>
+              <a:t>$3,797</a:t>
             </a:r>
           </a:p>
         </p:txBody>
@@ -6366,7 +6366,7 @@
         </p:nvSpPr>
         <p:spPr>
           <a:xfrm>
-            <a:off x="1794891" y="1519428"/>
+            <a:off x="1781174" y="1519428"/>
             <a:ext cx="457200" cy="219456"/>
           </a:xfrm>
           <a:prstGeom prst="rect">
@@ -6401,8 +6401,8 @@
         </p:nvSpPr>
         <p:spPr>
           <a:xfrm>
-            <a:off x="2305177" y="1519428"/>
-            <a:ext cx="1919351" cy="219456"/>
+            <a:off x="2291461" y="1519428"/>
+            <a:ext cx="1933067" cy="219456"/>
           </a:xfrm>
           <a:prstGeom prst="rect">
             <a:avLst/>
@@ -6423,7 +6423,7 @@
                 </a:solidFill>
                 <a:latin typeface="Poppins"/>
               </a:rPr>
-              <a:t>$3,797/mo</a:t>
+              <a:t/>
             </a:r>
           </a:p>
         </p:txBody>
@@ -6471,8 +6471,398 @@
         </p:nvSpPr>
         <p:spPr>
           <a:xfrm>
-            <a:off x="274320" y="2057400"/>
-            <a:ext cx="4041648" cy="960120"/>
+            <a:off x="274320" y="3108960"/>
+            <a:ext cx="4041648" cy="658368"/>
+          </a:xfrm>
+          <a:prstGeom prst="rect">
+            <a:avLst/>
+          </a:prstGeom>
+          <a:solidFill>
+            <a:srgbClr val="003A59"/>
+          </a:solidFill>
+          <a:ln>
+            <a:solidFill>
+              <a:srgbClr val="FFFFFF"/>
+            </a:solidFill>
+          </a:ln>
+        </p:spPr>
+        <p:style>
+          <a:lnRef idx="1">
+            <a:schemeClr val="accent1"/>
+          </a:lnRef>
+          <a:fillRef idx="3">
+            <a:schemeClr val="accent1"/>
+          </a:fillRef>
+          <a:effectRef idx="2">
+            <a:schemeClr val="accent1"/>
+          </a:effectRef>
+          <a:fontRef idx="minor">
+            <a:schemeClr val="lt1"/>
+          </a:fontRef>
+        </p:style>
+        <p:txBody>
+          <a:bodyPr rtlCol="0" anchor="ctr"/>
+          <a:lstStyle/>
+          <a:p>
+            <a:pPr algn="ctr"/>
+          </a:p>
+        </p:txBody>
+      </p:sp>
+      <p:sp>
+        <p:nvSpPr>
+          <p:cNvPr id="14" name="Rectangle 13"/>
+          <p:cNvSpPr/>
+          <p:nvPr/>
+        </p:nvSpPr>
+        <p:spPr>
+          <a:xfrm>
+            <a:off x="274320" y="3108960"/>
+            <a:ext cx="36576" cy="658368"/>
+          </a:xfrm>
+          <a:prstGeom prst="rect">
+            <a:avLst/>
+          </a:prstGeom>
+          <a:solidFill>
+            <a:srgbClr val="69CD2B"/>
+          </a:solidFill>
+          <a:ln>
+            <a:solidFill>
+              <a:srgbClr val="FFFFFF"/>
+            </a:solidFill>
+          </a:ln>
+        </p:spPr>
+        <p:style>
+          <a:lnRef idx="1">
+            <a:schemeClr val="accent1"/>
+          </a:lnRef>
+          <a:fillRef idx="3">
+            <a:schemeClr val="accent1"/>
+          </a:fillRef>
+          <a:effectRef idx="2">
+            <a:schemeClr val="accent1"/>
+          </a:effectRef>
+          <a:fontRef idx="minor">
+            <a:schemeClr val="lt1"/>
+          </a:fontRef>
+        </p:style>
+        <p:txBody>
+          <a:bodyPr rtlCol="0" anchor="ctr"/>
+          <a:lstStyle/>
+          <a:p>
+            <a:pPr algn="ctr"/>
+          </a:p>
+        </p:txBody>
+      </p:sp>
+      <p:sp>
+        <p:nvSpPr>
+          <p:cNvPr id="15" name="TextBox 14"/>
+          <p:cNvSpPr txBox="1"/>
+          <p:nvPr/>
+        </p:nvSpPr>
+        <p:spPr>
+          <a:xfrm>
+            <a:off x="512064" y="3200400"/>
+            <a:ext cx="1554480" cy="164592"/>
+          </a:xfrm>
+          <a:prstGeom prst="rect">
+            <a:avLst/>
+          </a:prstGeom>
+          <a:noFill/>
+        </p:spPr>
+        <p:txBody>
+          <a:bodyPr wrap="square">
+            <a:noAutofit/>
+          </a:bodyPr>
+          <a:lstStyle/>
+          <a:p>
+            <a:pPr algn="l"/>
+            <a:r>
+              <a:rPr sz="750" b="1" i="0">
+                <a:solidFill>
+                  <a:srgbClr val="69CD2B"/>
+                </a:solidFill>
+                <a:latin typeface="Poppins"/>
+              </a:rPr>
+              <a:t>BUNDLE TOTAL</a:t>
+            </a:r>
+          </a:p>
+        </p:txBody>
+      </p:sp>
+      <p:sp>
+        <p:nvSpPr>
+          <p:cNvPr id="16" name="TextBox 15"/>
+          <p:cNvSpPr txBox="1"/>
+          <p:nvPr/>
+        </p:nvSpPr>
+        <p:spPr>
+          <a:xfrm>
+            <a:off x="512064" y="3346704"/>
+            <a:ext cx="2194560" cy="365760"/>
+          </a:xfrm>
+          <a:prstGeom prst="rect">
+            <a:avLst/>
+          </a:prstGeom>
+          <a:noFill/>
+        </p:spPr>
+        <p:txBody>
+          <a:bodyPr wrap="square">
+            <a:noAutofit/>
+          </a:bodyPr>
+          <a:lstStyle/>
+          <a:p>
+            <a:pPr algn="l"/>
+            <a:r>
+              <a:rPr sz="1700" b="1" i="0">
+                <a:solidFill>
+                  <a:srgbClr val="FFFFFF"/>
+                </a:solidFill>
+                <a:latin typeface="Poppins"/>
+              </a:rPr>
+              <a:t>$3,797 / mo</a:t>
+            </a:r>
+          </a:p>
+        </p:txBody>
+      </p:sp>
+      <p:sp>
+        <p:nvSpPr>
+          <p:cNvPr id="17" name="TextBox 16"/>
+          <p:cNvSpPr txBox="1"/>
+          <p:nvPr/>
+        </p:nvSpPr>
+        <p:spPr>
+          <a:xfrm>
+            <a:off x="1948891" y="3460051"/>
+            <a:ext cx="2275636" cy="201168"/>
+          </a:xfrm>
+          <a:prstGeom prst="rect">
+            <a:avLst/>
+          </a:prstGeom>
+          <a:noFill/>
+        </p:spPr>
+        <p:txBody>
+          <a:bodyPr wrap="square">
+            <a:noAutofit/>
+          </a:bodyPr>
+          <a:lstStyle/>
+          <a:p>
+            <a:pPr algn="r"/>
+            <a:r>
+              <a:rPr sz="850" b="0" i="0">
+                <a:solidFill>
+                  <a:srgbClr val="A9D68C"/>
+                </a:solidFill>
+                <a:latin typeface="Poppins"/>
+              </a:rPr>
+              <a:t>Standalone — no bundle discount</a:t>
+            </a:r>
+          </a:p>
+        </p:txBody>
+      </p:sp>
+      <p:sp>
+        <p:nvSpPr>
+          <p:cNvPr id="18" name="TextBox 17"/>
+          <p:cNvSpPr txBox="1"/>
+          <p:nvPr/>
+        </p:nvSpPr>
+        <p:spPr>
+          <a:xfrm>
+            <a:off x="4572000" y="1005840"/>
+            <a:ext cx="4297680" cy="164592"/>
+          </a:xfrm>
+          <a:prstGeom prst="rect">
+            <a:avLst/>
+          </a:prstGeom>
+          <a:noFill/>
+        </p:spPr>
+        <p:txBody>
+          <a:bodyPr wrap="square">
+            <a:noAutofit/>
+          </a:bodyPr>
+          <a:lstStyle/>
+          <a:p>
+            <a:pPr algn="l"/>
+            <a:r>
+              <a:rPr sz="750" b="1" i="0">
+                <a:solidFill>
+                  <a:srgbClr val="003A59"/>
+                </a:solidFill>
+                <a:latin typeface="Poppins"/>
+              </a:rPr>
+              <a:t>HOW THIS PLAN ADDRESSES IT</a:t>
+            </a:r>
+          </a:p>
+        </p:txBody>
+      </p:sp>
+      <p:sp>
+        <p:nvSpPr>
+          <p:cNvPr id="19" name="Rectangle 18"/>
+          <p:cNvSpPr/>
+          <p:nvPr/>
+        </p:nvSpPr>
+        <p:spPr>
+          <a:xfrm>
+            <a:off x="4572000" y="1335024"/>
+            <a:ext cx="4297680" cy="265176"/>
+          </a:xfrm>
+          <a:prstGeom prst="rect">
+            <a:avLst/>
+          </a:prstGeom>
+          <a:solidFill>
+            <a:srgbClr val="EEF2F5"/>
+          </a:solidFill>
+          <a:ln>
+            <a:solidFill>
+              <a:srgbClr val="FFFFFF"/>
+            </a:solidFill>
+          </a:ln>
+        </p:spPr>
+        <p:style>
+          <a:lnRef idx="1">
+            <a:schemeClr val="accent1"/>
+          </a:lnRef>
+          <a:fillRef idx="3">
+            <a:schemeClr val="accent1"/>
+          </a:fillRef>
+          <a:effectRef idx="2">
+            <a:schemeClr val="accent1"/>
+          </a:effectRef>
+          <a:fontRef idx="minor">
+            <a:schemeClr val="lt1"/>
+          </a:fontRef>
+        </p:style>
+        <p:txBody>
+          <a:bodyPr rtlCol="0" anchor="ctr"/>
+          <a:lstStyle/>
+          <a:p>
+            <a:pPr algn="ctr"/>
+          </a:p>
+        </p:txBody>
+      </p:sp>
+      <p:sp>
+        <p:nvSpPr>
+          <p:cNvPr id="20" name="Rectangle 19"/>
+          <p:cNvSpPr/>
+          <p:nvPr/>
+        </p:nvSpPr>
+        <p:spPr>
+          <a:xfrm>
+            <a:off x="4700016" y="1417320"/>
+            <a:ext cx="91440" cy="91440"/>
+          </a:xfrm>
+          <a:prstGeom prst="rect">
+            <a:avLst/>
+          </a:prstGeom>
+          <a:solidFill>
+            <a:srgbClr val="69CD2B"/>
+          </a:solidFill>
+          <a:ln>
+            <a:solidFill>
+              <a:srgbClr val="FFFFFF"/>
+            </a:solidFill>
+          </a:ln>
+        </p:spPr>
+        <p:style>
+          <a:lnRef idx="1">
+            <a:schemeClr val="accent1"/>
+          </a:lnRef>
+          <a:fillRef idx="3">
+            <a:schemeClr val="accent1"/>
+          </a:fillRef>
+          <a:effectRef idx="2">
+            <a:schemeClr val="accent1"/>
+          </a:effectRef>
+          <a:fontRef idx="minor">
+            <a:schemeClr val="lt1"/>
+          </a:fontRef>
+        </p:style>
+        <p:txBody>
+          <a:bodyPr rtlCol="0" anchor="ctr"/>
+          <a:lstStyle/>
+          <a:p>
+            <a:pPr algn="ctr"/>
+          </a:p>
+        </p:txBody>
+      </p:sp>
+      <p:sp>
+        <p:nvSpPr>
+          <p:cNvPr id="21" name="TextBox 20"/>
+          <p:cNvSpPr txBox="1"/>
+          <p:nvPr/>
+        </p:nvSpPr>
+        <p:spPr>
+          <a:xfrm>
+            <a:off x="4846320" y="1335024"/>
+            <a:ext cx="1143000" cy="265176"/>
+          </a:xfrm>
+          <a:prstGeom prst="rect">
+            <a:avLst/>
+          </a:prstGeom>
+          <a:noFill/>
+        </p:spPr>
+        <p:txBody>
+          <a:bodyPr wrap="square" anchor="ctr">
+            <a:noAutofit/>
+          </a:bodyPr>
+          <a:lstStyle/>
+          <a:p>
+            <a:pPr algn="l"/>
+            <a:r>
+              <a:rPr sz="800" b="1" i="0">
+                <a:solidFill>
+                  <a:srgbClr val="003A59"/>
+                </a:solidFill>
+                <a:latin typeface="Poppins"/>
+              </a:rPr>
+              <a:t>AI setup time</a:t>
+            </a:r>
+          </a:p>
+        </p:txBody>
+      </p:sp>
+      <p:sp>
+        <p:nvSpPr>
+          <p:cNvPr id="22" name="TextBox 21"/>
+          <p:cNvSpPr txBox="1"/>
+          <p:nvPr/>
+        </p:nvSpPr>
+        <p:spPr>
+          <a:xfrm>
+            <a:off x="5943600" y="1335024"/>
+            <a:ext cx="2926080" cy="265176"/>
+          </a:xfrm>
+          <a:prstGeom prst="rect">
+            <a:avLst/>
+          </a:prstGeom>
+          <a:noFill/>
+        </p:spPr>
+        <p:txBody>
+          <a:bodyPr wrap="square" anchor="ctr">
+            <a:noAutofit/>
+          </a:bodyPr>
+          <a:lstStyle/>
+          <a:p>
+            <a:pPr algn="l"/>
+            <a:r>
+              <a:rPr sz="800" b="0" i="0">
+                <a:solidFill>
+                  <a:srgbClr val="4A5C6B"/>
+                </a:solidFill>
+                <a:latin typeface="Poppins"/>
+              </a:rPr>
+              <a:t>Your Fractional CTO leads the rollout monthly</a:t>
+            </a:r>
+          </a:p>
+        </p:txBody>
+      </p:sp>
+      <p:sp>
+        <p:nvSpPr>
+          <p:cNvPr id="23" name="Rectangle 22"/>
+          <p:cNvSpPr/>
+          <p:nvPr/>
+        </p:nvSpPr>
+        <p:spPr>
+          <a:xfrm>
+            <a:off x="4572000" y="1883664"/>
+            <a:ext cx="4297680" cy="265176"/>
           </a:xfrm>
           <a:prstGeom prst="rect">
             <a:avLst/>
@@ -6510,14 +6900,414 @@
       </p:sp>
       <p:sp>
         <p:nvSpPr>
-          <p:cNvPr id="14" name="Rectangle 13"/>
+          <p:cNvPr id="24" name="Rectangle 23"/>
           <p:cNvSpPr/>
           <p:nvPr/>
         </p:nvSpPr>
         <p:spPr>
           <a:xfrm>
-            <a:off x="274320" y="2057400"/>
-            <a:ext cx="36576" cy="960120"/>
+            <a:off x="4700016" y="1965960"/>
+            <a:ext cx="91440" cy="91440"/>
+          </a:xfrm>
+          <a:prstGeom prst="rect">
+            <a:avLst/>
+          </a:prstGeom>
+          <a:solidFill>
+            <a:srgbClr val="0091C9"/>
+          </a:solidFill>
+          <a:ln>
+            <a:solidFill>
+              <a:srgbClr val="FFFFFF"/>
+            </a:solidFill>
+          </a:ln>
+        </p:spPr>
+        <p:style>
+          <a:lnRef idx="1">
+            <a:schemeClr val="accent1"/>
+          </a:lnRef>
+          <a:fillRef idx="3">
+            <a:schemeClr val="accent1"/>
+          </a:fillRef>
+          <a:effectRef idx="2">
+            <a:schemeClr val="accent1"/>
+          </a:effectRef>
+          <a:fontRef idx="minor">
+            <a:schemeClr val="lt1"/>
+          </a:fontRef>
+        </p:style>
+        <p:txBody>
+          <a:bodyPr rtlCol="0" anchor="ctr"/>
+          <a:lstStyle/>
+          <a:p>
+            <a:pPr algn="ctr"/>
+          </a:p>
+        </p:txBody>
+      </p:sp>
+      <p:sp>
+        <p:nvSpPr>
+          <p:cNvPr id="25" name="TextBox 24"/>
+          <p:cNvSpPr txBox="1"/>
+          <p:nvPr/>
+        </p:nvSpPr>
+        <p:spPr>
+          <a:xfrm>
+            <a:off x="4846320" y="1883664"/>
+            <a:ext cx="1143000" cy="265176"/>
+          </a:xfrm>
+          <a:prstGeom prst="rect">
+            <a:avLst/>
+          </a:prstGeom>
+          <a:noFill/>
+        </p:spPr>
+        <p:txBody>
+          <a:bodyPr wrap="square" anchor="ctr">
+            <a:noAutofit/>
+          </a:bodyPr>
+          <a:lstStyle/>
+          <a:p>
+            <a:pPr algn="l"/>
+            <a:r>
+              <a:rPr sz="800" b="1" i="0">
+                <a:solidFill>
+                  <a:srgbClr val="003A59"/>
+                </a:solidFill>
+                <a:latin typeface="Poppins"/>
+              </a:rPr>
+              <a:t>Follow-up time</a:t>
+            </a:r>
+          </a:p>
+        </p:txBody>
+      </p:sp>
+      <p:sp>
+        <p:nvSpPr>
+          <p:cNvPr id="26" name="TextBox 25"/>
+          <p:cNvSpPr txBox="1"/>
+          <p:nvPr/>
+        </p:nvSpPr>
+        <p:spPr>
+          <a:xfrm>
+            <a:off x="5943600" y="1883664"/>
+            <a:ext cx="2926080" cy="265176"/>
+          </a:xfrm>
+          <a:prstGeom prst="rect">
+            <a:avLst/>
+          </a:prstGeom>
+          <a:noFill/>
+        </p:spPr>
+        <p:txBody>
+          <a:bodyPr wrap="square" anchor="ctr">
+            <a:noAutofit/>
+          </a:bodyPr>
+          <a:lstStyle/>
+          <a:p>
+            <a:pPr algn="l"/>
+            <a:r>
+              <a:rPr sz="800" b="0" i="0">
+                <a:solidFill>
+                  <a:srgbClr val="4A5C6B"/>
+                </a:solidFill>
+                <a:latin typeface="Poppins"/>
+              </a:rPr>
+              <a:t>A monthly custom automation takes it on</a:t>
+            </a:r>
+          </a:p>
+        </p:txBody>
+      </p:sp>
+      <p:sp>
+        <p:nvSpPr>
+          <p:cNvPr id="27" name="Rectangle 26"/>
+          <p:cNvSpPr/>
+          <p:nvPr/>
+        </p:nvSpPr>
+        <p:spPr>
+          <a:xfrm>
+            <a:off x="4572000" y="2432304"/>
+            <a:ext cx="4297680" cy="265176"/>
+          </a:xfrm>
+          <a:prstGeom prst="rect">
+            <a:avLst/>
+          </a:prstGeom>
+          <a:solidFill>
+            <a:srgbClr val="EEF2F5"/>
+          </a:solidFill>
+          <a:ln>
+            <a:solidFill>
+              <a:srgbClr val="FFFFFF"/>
+            </a:solidFill>
+          </a:ln>
+        </p:spPr>
+        <p:style>
+          <a:lnRef idx="1">
+            <a:schemeClr val="accent1"/>
+          </a:lnRef>
+          <a:fillRef idx="3">
+            <a:schemeClr val="accent1"/>
+          </a:fillRef>
+          <a:effectRef idx="2">
+            <a:schemeClr val="accent1"/>
+          </a:effectRef>
+          <a:fontRef idx="minor">
+            <a:schemeClr val="lt1"/>
+          </a:fontRef>
+        </p:style>
+        <p:txBody>
+          <a:bodyPr rtlCol="0" anchor="ctr"/>
+          <a:lstStyle/>
+          <a:p>
+            <a:pPr algn="ctr"/>
+          </a:p>
+        </p:txBody>
+      </p:sp>
+      <p:sp>
+        <p:nvSpPr>
+          <p:cNvPr id="28" name="Rectangle 27"/>
+          <p:cNvSpPr/>
+          <p:nvPr/>
+        </p:nvSpPr>
+        <p:spPr>
+          <a:xfrm>
+            <a:off x="4700016" y="2514600"/>
+            <a:ext cx="91440" cy="91440"/>
+          </a:xfrm>
+          <a:prstGeom prst="rect">
+            <a:avLst/>
+          </a:prstGeom>
+          <a:solidFill>
+            <a:srgbClr val="0091C9"/>
+          </a:solidFill>
+          <a:ln>
+            <a:solidFill>
+              <a:srgbClr val="FFFFFF"/>
+            </a:solidFill>
+          </a:ln>
+        </p:spPr>
+        <p:style>
+          <a:lnRef idx="1">
+            <a:schemeClr val="accent1"/>
+          </a:lnRef>
+          <a:fillRef idx="3">
+            <a:schemeClr val="accent1"/>
+          </a:fillRef>
+          <a:effectRef idx="2">
+            <a:schemeClr val="accent1"/>
+          </a:effectRef>
+          <a:fontRef idx="minor">
+            <a:schemeClr val="lt1"/>
+          </a:fontRef>
+        </p:style>
+        <p:txBody>
+          <a:bodyPr rtlCol="0" anchor="ctr"/>
+          <a:lstStyle/>
+          <a:p>
+            <a:pPr algn="ctr"/>
+          </a:p>
+        </p:txBody>
+      </p:sp>
+      <p:sp>
+        <p:nvSpPr>
+          <p:cNvPr id="29" name="TextBox 28"/>
+          <p:cNvSpPr txBox="1"/>
+          <p:nvPr/>
+        </p:nvSpPr>
+        <p:spPr>
+          <a:xfrm>
+            <a:off x="4846320" y="2432304"/>
+            <a:ext cx="1143000" cy="265176"/>
+          </a:xfrm>
+          <a:prstGeom prst="rect">
+            <a:avLst/>
+          </a:prstGeom>
+          <a:noFill/>
+        </p:spPr>
+        <p:txBody>
+          <a:bodyPr wrap="square" anchor="ctr">
+            <a:noAutofit/>
+          </a:bodyPr>
+          <a:lstStyle/>
+          <a:p>
+            <a:pPr algn="l"/>
+            <a:r>
+              <a:rPr sz="800" b="1" i="0">
+                <a:solidFill>
+                  <a:srgbClr val="003A59"/>
+                </a:solidFill>
+                <a:latin typeface="Poppins"/>
+              </a:rPr>
+              <a:t>No idle payroll</a:t>
+            </a:r>
+          </a:p>
+        </p:txBody>
+      </p:sp>
+      <p:sp>
+        <p:nvSpPr>
+          <p:cNvPr id="30" name="TextBox 29"/>
+          <p:cNvSpPr txBox="1"/>
+          <p:nvPr/>
+        </p:nvSpPr>
+        <p:spPr>
+          <a:xfrm>
+            <a:off x="5943600" y="2432304"/>
+            <a:ext cx="2926080" cy="265176"/>
+          </a:xfrm>
+          <a:prstGeom prst="rect">
+            <a:avLst/>
+          </a:prstGeom>
+          <a:noFill/>
+        </p:spPr>
+        <p:txBody>
+          <a:bodyPr wrap="square" anchor="ctr">
+            <a:noAutofit/>
+          </a:bodyPr>
+          <a:lstStyle/>
+          <a:p>
+            <a:pPr algn="l"/>
+            <a:r>
+              <a:rPr sz="800" b="0" i="0">
+                <a:solidFill>
+                  <a:srgbClr val="4A5C6B"/>
+                </a:solidFill>
+                <a:latin typeface="Poppins"/>
+              </a:rPr>
+              <a:t>Skills and automations add capacity, not salary</a:t>
+            </a:r>
+          </a:p>
+        </p:txBody>
+      </p:sp>
+      <p:sp>
+        <p:nvSpPr>
+          <p:cNvPr id="31" name="Rectangle 30"/>
+          <p:cNvSpPr/>
+          <p:nvPr/>
+        </p:nvSpPr>
+        <p:spPr>
+          <a:xfrm>
+            <a:off x="0" y="4261104"/>
+            <a:ext cx="9144000" cy="557784"/>
+          </a:xfrm>
+          <a:prstGeom prst="rect">
+            <a:avLst/>
+          </a:prstGeom>
+          <a:solidFill>
+            <a:srgbClr val="002A41"/>
+          </a:solidFill>
+          <a:ln>
+            <a:solidFill>
+              <a:srgbClr val="FFFFFF"/>
+            </a:solidFill>
+          </a:ln>
+        </p:spPr>
+        <p:style>
+          <a:lnRef idx="1">
+            <a:schemeClr val="accent1"/>
+          </a:lnRef>
+          <a:fillRef idx="3">
+            <a:schemeClr val="accent1"/>
+          </a:fillRef>
+          <a:effectRef idx="2">
+            <a:schemeClr val="accent1"/>
+          </a:effectRef>
+          <a:fontRef idx="minor">
+            <a:schemeClr val="lt1"/>
+          </a:fontRef>
+        </p:style>
+        <p:txBody>
+          <a:bodyPr rtlCol="0" anchor="ctr"/>
+          <a:lstStyle/>
+          <a:p>
+            <a:pPr algn="ctr"/>
+          </a:p>
+        </p:txBody>
+      </p:sp>
+      <p:sp>
+        <p:nvSpPr>
+          <p:cNvPr id="32" name="Rectangle 31"/>
+          <p:cNvSpPr/>
+          <p:nvPr/>
+        </p:nvSpPr>
+        <p:spPr>
+          <a:xfrm>
+            <a:off x="0" y="4261104"/>
+            <a:ext cx="9144000" cy="18288"/>
+          </a:xfrm>
+          <a:prstGeom prst="rect">
+            <a:avLst/>
+          </a:prstGeom>
+          <a:solidFill>
+            <a:srgbClr val="69CD2B"/>
+          </a:solidFill>
+          <a:ln>
+            <a:solidFill>
+              <a:srgbClr val="FFFFFF"/>
+            </a:solidFill>
+          </a:ln>
+        </p:spPr>
+        <p:style>
+          <a:lnRef idx="1">
+            <a:schemeClr val="accent1"/>
+          </a:lnRef>
+          <a:fillRef idx="3">
+            <a:schemeClr val="accent1"/>
+          </a:fillRef>
+          <a:effectRef idx="2">
+            <a:schemeClr val="accent1"/>
+          </a:effectRef>
+          <a:fontRef idx="minor">
+            <a:schemeClr val="lt1"/>
+          </a:fontRef>
+        </p:style>
+        <p:txBody>
+          <a:bodyPr rtlCol="0" anchor="ctr"/>
+          <a:lstStyle/>
+          <a:p>
+            <a:pPr algn="ctr"/>
+          </a:p>
+        </p:txBody>
+      </p:sp>
+      <p:sp>
+        <p:nvSpPr>
+          <p:cNvPr id="33" name="TextBox 32"/>
+          <p:cNvSpPr txBox="1"/>
+          <p:nvPr/>
+        </p:nvSpPr>
+        <p:spPr>
+          <a:xfrm>
+            <a:off x="640080" y="4297680"/>
+            <a:ext cx="7863840" cy="493776"/>
+          </a:xfrm>
+          <a:prstGeom prst="rect">
+            <a:avLst/>
+          </a:prstGeom>
+          <a:noFill/>
+        </p:spPr>
+        <p:txBody>
+          <a:bodyPr wrap="square" anchor="ctr">
+            <a:noAutofit/>
+          </a:bodyPr>
+          <a:lstStyle/>
+          <a:p>
+            <a:pPr algn="ctr"/>
+            <a:r>
+              <a:rPr sz="950" b="0" i="0">
+                <a:solidFill>
+                  <a:srgbClr val="C2D8E6"/>
+                </a:solidFill>
+                <a:latin typeface="Poppins"/>
+              </a:rPr>
+              <a:t>"Someone just comes in and says, bam, this is working for you, let's go — and I get back to the legal work only I can do."</a:t>
+            </a:r>
+          </a:p>
+        </p:txBody>
+      </p:sp>
+      <p:sp>
+        <p:nvSpPr>
+          <p:cNvPr id="34" name="Rectangle 33"/>
+          <p:cNvSpPr/>
+          <p:nvPr/>
+        </p:nvSpPr>
+        <p:spPr>
+          <a:xfrm>
+            <a:off x="0" y="4818888"/>
+            <a:ext cx="9144000" cy="320040"/>
           </a:xfrm>
           <a:prstGeom prst="rect">
             <a:avLst/>
@@ -6553,1064 +7343,9 @@
           </a:p>
         </p:txBody>
       </p:sp>
-      <p:sp>
-        <p:nvSpPr>
-          <p:cNvPr id="15" name="TextBox 14"/>
-          <p:cNvSpPr txBox="1"/>
-          <p:nvPr/>
-        </p:nvSpPr>
-        <p:spPr>
-          <a:xfrm>
-            <a:off x="512064" y="2167128"/>
-            <a:ext cx="3621024" cy="182880"/>
-          </a:xfrm>
-          <a:prstGeom prst="rect">
-            <a:avLst/>
-          </a:prstGeom>
-          <a:noFill/>
-        </p:spPr>
-        <p:txBody>
-          <a:bodyPr wrap="square">
-            <a:noAutofit/>
-          </a:bodyPr>
-          <a:lstStyle/>
-          <a:p>
-            <a:pPr algn="l"/>
-            <a:r>
-              <a:rPr sz="750" b="1" i="0">
-                <a:solidFill>
-                  <a:srgbClr val="003A59"/>
-                </a:solidFill>
-                <a:latin typeface="Poppins"/>
-              </a:rPr>
-              <a:t>AI WORKFORCE PRO — 10 USERS</a:t>
-            </a:r>
-          </a:p>
-        </p:txBody>
-      </p:sp>
-      <p:sp>
-        <p:nvSpPr>
-          <p:cNvPr id="16" name="TextBox 15"/>
-          <p:cNvSpPr txBox="1"/>
-          <p:nvPr/>
-        </p:nvSpPr>
-        <p:spPr>
-          <a:xfrm>
-            <a:off x="512064" y="2304288"/>
-            <a:ext cx="2377440" cy="530352"/>
-          </a:xfrm>
-          <a:prstGeom prst="rect">
-            <a:avLst/>
-          </a:prstGeom>
-          <a:noFill/>
-        </p:spPr>
-        <p:txBody>
-          <a:bodyPr wrap="square">
-            <a:noAutofit/>
-          </a:bodyPr>
-          <a:lstStyle/>
-          <a:p>
-            <a:pPr algn="l"/>
-            <a:r>
-              <a:rPr sz="3000" b="1" i="0">
-                <a:solidFill>
-                  <a:srgbClr val="003A59"/>
-                </a:solidFill>
-                <a:latin typeface="Poppins"/>
-              </a:rPr>
-              <a:t>$2,197</a:t>
-            </a:r>
-          </a:p>
-        </p:txBody>
-      </p:sp>
-      <p:sp>
-        <p:nvSpPr>
-          <p:cNvPr id="17" name="TextBox 16"/>
-          <p:cNvSpPr txBox="1"/>
-          <p:nvPr/>
-        </p:nvSpPr>
-        <p:spPr>
-          <a:xfrm>
-            <a:off x="1707642" y="2570988"/>
-            <a:ext cx="457200" cy="219456"/>
-          </a:xfrm>
-          <a:prstGeom prst="rect">
-            <a:avLst/>
-          </a:prstGeom>
-          <a:noFill/>
-        </p:spPr>
-        <p:txBody>
-          <a:bodyPr wrap="none">
-            <a:noAutofit/>
-          </a:bodyPr>
-          <a:lstStyle/>
-          <a:p>
-            <a:pPr algn="l"/>
-            <a:r>
-              <a:rPr sz="1000" b="0" i="0">
-                <a:solidFill>
-                  <a:srgbClr val="7C8D9B"/>
-                </a:solidFill>
-                <a:latin typeface="Poppins"/>
-              </a:rPr>
-              <a:t>/mo</a:t>
-            </a:r>
-          </a:p>
-        </p:txBody>
-      </p:sp>
-      <p:sp>
-        <p:nvSpPr>
-          <p:cNvPr id="18" name="TextBox 17"/>
-          <p:cNvSpPr txBox="1"/>
-          <p:nvPr/>
-        </p:nvSpPr>
-        <p:spPr>
-          <a:xfrm>
-            <a:off x="2217928" y="2570988"/>
-            <a:ext cx="2006599" cy="219456"/>
-          </a:xfrm>
-          <a:prstGeom prst="rect">
-            <a:avLst/>
-          </a:prstGeom>
-          <a:noFill/>
-        </p:spPr>
-        <p:txBody>
-          <a:bodyPr wrap="square">
-            <a:noAutofit/>
-          </a:bodyPr>
-          <a:lstStyle/>
-          <a:p>
-            <a:pPr algn="r"/>
-            <a:r>
-              <a:rPr sz="1000" b="0" i="0">
-                <a:solidFill>
-                  <a:srgbClr val="7C8D9B"/>
-                </a:solidFill>
-                <a:latin typeface="Poppins"/>
-              </a:rPr>
-              <a:t/>
-            </a:r>
-          </a:p>
-        </p:txBody>
-      </p:sp>
-      <p:sp>
-        <p:nvSpPr>
-          <p:cNvPr id="19" name="TextBox 18"/>
-          <p:cNvSpPr txBox="1"/>
-          <p:nvPr/>
-        </p:nvSpPr>
-        <p:spPr>
-          <a:xfrm>
-            <a:off x="512064" y="2788920"/>
-            <a:ext cx="3621024" cy="201168"/>
-          </a:xfrm>
-          <a:prstGeom prst="rect">
-            <a:avLst/>
-          </a:prstGeom>
-          <a:noFill/>
-        </p:spPr>
-        <p:txBody>
-          <a:bodyPr wrap="square">
-            <a:noAutofit/>
-          </a:bodyPr>
-          <a:lstStyle/>
-          <a:p>
-            <a:pPr algn="l"/>
-            <a:r>
-              <a:rPr sz="850" b="0" i="0">
-                <a:solidFill>
-                  <a:srgbClr val="7C8D9B"/>
-                </a:solidFill>
-                <a:latin typeface="Poppins"/>
-              </a:rPr>
-              <a:t>Managed AI workspace · Weekly implementation session</a:t>
-            </a:r>
-          </a:p>
-        </p:txBody>
-      </p:sp>
-      <p:sp>
-        <p:nvSpPr>
-          <p:cNvPr id="20" name="Rectangle 19"/>
-          <p:cNvSpPr/>
-          <p:nvPr/>
-        </p:nvSpPr>
-        <p:spPr>
-          <a:xfrm>
-            <a:off x="274320" y="3108960"/>
-            <a:ext cx="4041648" cy="658368"/>
-          </a:xfrm>
-          <a:prstGeom prst="rect">
-            <a:avLst/>
-          </a:prstGeom>
-          <a:solidFill>
-            <a:srgbClr val="003A59"/>
-          </a:solidFill>
-          <a:ln>
-            <a:solidFill>
-              <a:srgbClr val="FFFFFF"/>
-            </a:solidFill>
-          </a:ln>
-        </p:spPr>
-        <p:style>
-          <a:lnRef idx="1">
-            <a:schemeClr val="accent1"/>
-          </a:lnRef>
-          <a:fillRef idx="3">
-            <a:schemeClr val="accent1"/>
-          </a:fillRef>
-          <a:effectRef idx="2">
-            <a:schemeClr val="accent1"/>
-          </a:effectRef>
-          <a:fontRef idx="minor">
-            <a:schemeClr val="lt1"/>
-          </a:fontRef>
-        </p:style>
-        <p:txBody>
-          <a:bodyPr rtlCol="0" anchor="ctr"/>
-          <a:lstStyle/>
-          <a:p>
-            <a:pPr algn="ctr"/>
-          </a:p>
-        </p:txBody>
-      </p:sp>
-      <p:sp>
-        <p:nvSpPr>
-          <p:cNvPr id="21" name="Rectangle 20"/>
-          <p:cNvSpPr/>
-          <p:nvPr/>
-        </p:nvSpPr>
-        <p:spPr>
-          <a:xfrm>
-            <a:off x="274320" y="3108960"/>
-            <a:ext cx="36576" cy="658368"/>
-          </a:xfrm>
-          <a:prstGeom prst="rect">
-            <a:avLst/>
-          </a:prstGeom>
-          <a:solidFill>
-            <a:srgbClr val="69CD2B"/>
-          </a:solidFill>
-          <a:ln>
-            <a:solidFill>
-              <a:srgbClr val="FFFFFF"/>
-            </a:solidFill>
-          </a:ln>
-        </p:spPr>
-        <p:style>
-          <a:lnRef idx="1">
-            <a:schemeClr val="accent1"/>
-          </a:lnRef>
-          <a:fillRef idx="3">
-            <a:schemeClr val="accent1"/>
-          </a:fillRef>
-          <a:effectRef idx="2">
-            <a:schemeClr val="accent1"/>
-          </a:effectRef>
-          <a:fontRef idx="minor">
-            <a:schemeClr val="lt1"/>
-          </a:fontRef>
-        </p:style>
-        <p:txBody>
-          <a:bodyPr rtlCol="0" anchor="ctr"/>
-          <a:lstStyle/>
-          <a:p>
-            <a:pPr algn="ctr"/>
-          </a:p>
-        </p:txBody>
-      </p:sp>
-      <p:sp>
-        <p:nvSpPr>
-          <p:cNvPr id="22" name="TextBox 21"/>
-          <p:cNvSpPr txBox="1"/>
-          <p:nvPr/>
-        </p:nvSpPr>
-        <p:spPr>
-          <a:xfrm>
-            <a:off x="512064" y="3200400"/>
-            <a:ext cx="1554480" cy="164592"/>
-          </a:xfrm>
-          <a:prstGeom prst="rect">
-            <a:avLst/>
-          </a:prstGeom>
-          <a:noFill/>
-        </p:spPr>
-        <p:txBody>
-          <a:bodyPr wrap="square">
-            <a:noAutofit/>
-          </a:bodyPr>
-          <a:lstStyle/>
-          <a:p>
-            <a:pPr algn="l"/>
-            <a:r>
-              <a:rPr sz="750" b="1" i="0">
-                <a:solidFill>
-                  <a:srgbClr val="69CD2B"/>
-                </a:solidFill>
-                <a:latin typeface="Poppins"/>
-              </a:rPr>
-              <a:t>BUNDLE TOTAL</a:t>
-            </a:r>
-          </a:p>
-        </p:txBody>
-      </p:sp>
-      <p:sp>
-        <p:nvSpPr>
-          <p:cNvPr id="23" name="TextBox 22"/>
-          <p:cNvSpPr txBox="1"/>
-          <p:nvPr/>
-        </p:nvSpPr>
-        <p:spPr>
-          <a:xfrm>
-            <a:off x="512064" y="3346704"/>
-            <a:ext cx="2194560" cy="365760"/>
-          </a:xfrm>
-          <a:prstGeom prst="rect">
-            <a:avLst/>
-          </a:prstGeom>
-          <a:noFill/>
-        </p:spPr>
-        <p:txBody>
-          <a:bodyPr wrap="square">
-            <a:noAutofit/>
-          </a:bodyPr>
-          <a:lstStyle/>
-          <a:p>
-            <a:pPr algn="l"/>
-            <a:r>
-              <a:rPr sz="1700" b="1" i="0">
-                <a:solidFill>
-                  <a:srgbClr val="FFFFFF"/>
-                </a:solidFill>
-                <a:latin typeface="Poppins"/>
-              </a:rPr>
-              <a:t>$5,494 / mo</a:t>
-            </a:r>
-          </a:p>
-        </p:txBody>
-      </p:sp>
-      <p:sp>
-        <p:nvSpPr>
-          <p:cNvPr id="24" name="TextBox 23"/>
-          <p:cNvSpPr txBox="1"/>
-          <p:nvPr/>
-        </p:nvSpPr>
-        <p:spPr>
-          <a:xfrm>
-            <a:off x="2019922" y="3460051"/>
-            <a:ext cx="2204605" cy="201168"/>
-          </a:xfrm>
-          <a:prstGeom prst="rect">
-            <a:avLst/>
-          </a:prstGeom>
-          <a:noFill/>
-        </p:spPr>
-        <p:txBody>
-          <a:bodyPr wrap="square">
-            <a:noAutofit/>
-          </a:bodyPr>
-          <a:lstStyle/>
-          <a:p>
-            <a:pPr algn="r"/>
-            <a:r>
-              <a:rPr sz="850" b="0" i="0">
-                <a:solidFill>
-                  <a:srgbClr val="A9D68C"/>
-                </a:solidFill>
-                <a:latin typeface="Poppins"/>
-              </a:rPr>
-              <a:t>Save $500/mo by bundling</a:t>
-            </a:r>
-          </a:p>
-        </p:txBody>
-      </p:sp>
-      <p:sp>
-        <p:nvSpPr>
-          <p:cNvPr id="25" name="TextBox 24"/>
-          <p:cNvSpPr txBox="1"/>
-          <p:nvPr/>
-        </p:nvSpPr>
-        <p:spPr>
-          <a:xfrm>
-            <a:off x="4572000" y="1005840"/>
-            <a:ext cx="4297680" cy="164592"/>
-          </a:xfrm>
-          <a:prstGeom prst="rect">
-            <a:avLst/>
-          </a:prstGeom>
-          <a:noFill/>
-        </p:spPr>
-        <p:txBody>
-          <a:bodyPr wrap="square">
-            <a:noAutofit/>
-          </a:bodyPr>
-          <a:lstStyle/>
-          <a:p>
-            <a:pPr algn="l"/>
-            <a:r>
-              <a:rPr sz="750" b="1" i="0">
-                <a:solidFill>
-                  <a:srgbClr val="003A59"/>
-                </a:solidFill>
-                <a:latin typeface="Poppins"/>
-              </a:rPr>
-              <a:t>HOW THIS PLAN ADDRESSES IT</a:t>
-            </a:r>
-          </a:p>
-        </p:txBody>
-      </p:sp>
-      <p:sp>
-        <p:nvSpPr>
-          <p:cNvPr id="26" name="Rectangle 25"/>
-          <p:cNvSpPr/>
-          <p:nvPr/>
-        </p:nvSpPr>
-        <p:spPr>
-          <a:xfrm>
-            <a:off x="4572000" y="1335024"/>
-            <a:ext cx="4297680" cy="265176"/>
-          </a:xfrm>
-          <a:prstGeom prst="rect">
-            <a:avLst/>
-          </a:prstGeom>
-          <a:solidFill>
-            <a:srgbClr val="EEF2F5"/>
-          </a:solidFill>
-          <a:ln>
-            <a:solidFill>
-              <a:srgbClr val="FFFFFF"/>
-            </a:solidFill>
-          </a:ln>
-        </p:spPr>
-        <p:style>
-          <a:lnRef idx="1">
-            <a:schemeClr val="accent1"/>
-          </a:lnRef>
-          <a:fillRef idx="3">
-            <a:schemeClr val="accent1"/>
-          </a:fillRef>
-          <a:effectRef idx="2">
-            <a:schemeClr val="accent1"/>
-          </a:effectRef>
-          <a:fontRef idx="minor">
-            <a:schemeClr val="lt1"/>
-          </a:fontRef>
-        </p:style>
-        <p:txBody>
-          <a:bodyPr rtlCol="0" anchor="ctr"/>
-          <a:lstStyle/>
-          <a:p>
-            <a:pPr algn="ctr"/>
-          </a:p>
-        </p:txBody>
-      </p:sp>
-      <p:sp>
-        <p:nvSpPr>
-          <p:cNvPr id="27" name="Rectangle 26"/>
-          <p:cNvSpPr/>
-          <p:nvPr/>
-        </p:nvSpPr>
-        <p:spPr>
-          <a:xfrm>
-            <a:off x="4700016" y="1417320"/>
-            <a:ext cx="91440" cy="91440"/>
-          </a:xfrm>
-          <a:prstGeom prst="rect">
-            <a:avLst/>
-          </a:prstGeom>
-          <a:solidFill>
-            <a:srgbClr val="69CD2B"/>
-          </a:solidFill>
-          <a:ln>
-            <a:solidFill>
-              <a:srgbClr val="FFFFFF"/>
-            </a:solidFill>
-          </a:ln>
-        </p:spPr>
-        <p:style>
-          <a:lnRef idx="1">
-            <a:schemeClr val="accent1"/>
-          </a:lnRef>
-          <a:fillRef idx="3">
-            <a:schemeClr val="accent1"/>
-          </a:fillRef>
-          <a:effectRef idx="2">
-            <a:schemeClr val="accent1"/>
-          </a:effectRef>
-          <a:fontRef idx="minor">
-            <a:schemeClr val="lt1"/>
-          </a:fontRef>
-        </p:style>
-        <p:txBody>
-          <a:bodyPr rtlCol="0" anchor="ctr"/>
-          <a:lstStyle/>
-          <a:p>
-            <a:pPr algn="ctr"/>
-          </a:p>
-        </p:txBody>
-      </p:sp>
-      <p:sp>
-        <p:nvSpPr>
-          <p:cNvPr id="28" name="TextBox 27"/>
-          <p:cNvSpPr txBox="1"/>
-          <p:nvPr/>
-        </p:nvSpPr>
-        <p:spPr>
-          <a:xfrm>
-            <a:off x="4846320" y="1335024"/>
-            <a:ext cx="1143000" cy="265176"/>
-          </a:xfrm>
-          <a:prstGeom prst="rect">
-            <a:avLst/>
-          </a:prstGeom>
-          <a:noFill/>
-        </p:spPr>
-        <p:txBody>
-          <a:bodyPr wrap="square" anchor="ctr">
-            <a:noAutofit/>
-          </a:bodyPr>
-          <a:lstStyle/>
-          <a:p>
-            <a:pPr algn="l"/>
-            <a:r>
-              <a:rPr sz="800" b="1" i="0">
-                <a:solidFill>
-                  <a:srgbClr val="003A59"/>
-                </a:solidFill>
-                <a:latin typeface="Poppins"/>
-              </a:rPr>
-              <a:t>AI setup time</a:t>
-            </a:r>
-          </a:p>
-        </p:txBody>
-      </p:sp>
-      <p:sp>
-        <p:nvSpPr>
-          <p:cNvPr id="29" name="TextBox 28"/>
-          <p:cNvSpPr txBox="1"/>
-          <p:nvPr/>
-        </p:nvSpPr>
-        <p:spPr>
-          <a:xfrm>
-            <a:off x="5943600" y="1335024"/>
-            <a:ext cx="2926080" cy="265176"/>
-          </a:xfrm>
-          <a:prstGeom prst="rect">
-            <a:avLst/>
-          </a:prstGeom>
-          <a:noFill/>
-        </p:spPr>
-        <p:txBody>
-          <a:bodyPr wrap="square" anchor="ctr">
-            <a:noAutofit/>
-          </a:bodyPr>
-          <a:lstStyle/>
-          <a:p>
-            <a:pPr algn="l"/>
-            <a:r>
-              <a:rPr sz="800" b="0" i="0">
-                <a:solidFill>
-                  <a:srgbClr val="4A5C6B"/>
-                </a:solidFill>
-                <a:latin typeface="Poppins"/>
-              </a:rPr>
-              <a:t>Your Fractional CTO leads the rollout monthly</a:t>
-            </a:r>
-          </a:p>
-        </p:txBody>
-      </p:sp>
-      <p:sp>
-        <p:nvSpPr>
-          <p:cNvPr id="30" name="Rectangle 29"/>
-          <p:cNvSpPr/>
-          <p:nvPr/>
-        </p:nvSpPr>
-        <p:spPr>
-          <a:xfrm>
-            <a:off x="4572000" y="1883664"/>
-            <a:ext cx="4297680" cy="265176"/>
-          </a:xfrm>
-          <a:prstGeom prst="rect">
-            <a:avLst/>
-          </a:prstGeom>
-          <a:solidFill>
-            <a:srgbClr val="FFFFFF"/>
-          </a:solidFill>
-          <a:ln>
-            <a:solidFill>
-              <a:srgbClr val="FFFFFF"/>
-            </a:solidFill>
-          </a:ln>
-        </p:spPr>
-        <p:style>
-          <a:lnRef idx="1">
-            <a:schemeClr val="accent1"/>
-          </a:lnRef>
-          <a:fillRef idx="3">
-            <a:schemeClr val="accent1"/>
-          </a:fillRef>
-          <a:effectRef idx="2">
-            <a:schemeClr val="accent1"/>
-          </a:effectRef>
-          <a:fontRef idx="minor">
-            <a:schemeClr val="lt1"/>
-          </a:fontRef>
-        </p:style>
-        <p:txBody>
-          <a:bodyPr rtlCol="0" anchor="ctr"/>
-          <a:lstStyle/>
-          <a:p>
-            <a:pPr algn="ctr"/>
-          </a:p>
-        </p:txBody>
-      </p:sp>
-      <p:sp>
-        <p:nvSpPr>
-          <p:cNvPr id="31" name="Rectangle 30"/>
-          <p:cNvSpPr/>
-          <p:nvPr/>
-        </p:nvSpPr>
-        <p:spPr>
-          <a:xfrm>
-            <a:off x="4700016" y="1965960"/>
-            <a:ext cx="91440" cy="91440"/>
-          </a:xfrm>
-          <a:prstGeom prst="rect">
-            <a:avLst/>
-          </a:prstGeom>
-          <a:solidFill>
-            <a:srgbClr val="0091C9"/>
-          </a:solidFill>
-          <a:ln>
-            <a:solidFill>
-              <a:srgbClr val="FFFFFF"/>
-            </a:solidFill>
-          </a:ln>
-        </p:spPr>
-        <p:style>
-          <a:lnRef idx="1">
-            <a:schemeClr val="accent1"/>
-          </a:lnRef>
-          <a:fillRef idx="3">
-            <a:schemeClr val="accent1"/>
-          </a:fillRef>
-          <a:effectRef idx="2">
-            <a:schemeClr val="accent1"/>
-          </a:effectRef>
-          <a:fontRef idx="minor">
-            <a:schemeClr val="lt1"/>
-          </a:fontRef>
-        </p:style>
-        <p:txBody>
-          <a:bodyPr rtlCol="0" anchor="ctr"/>
-          <a:lstStyle/>
-          <a:p>
-            <a:pPr algn="ctr"/>
-          </a:p>
-        </p:txBody>
-      </p:sp>
-      <p:sp>
-        <p:nvSpPr>
-          <p:cNvPr id="32" name="TextBox 31"/>
-          <p:cNvSpPr txBox="1"/>
-          <p:nvPr/>
-        </p:nvSpPr>
-        <p:spPr>
-          <a:xfrm>
-            <a:off x="4846320" y="1883664"/>
-            <a:ext cx="1143000" cy="265176"/>
-          </a:xfrm>
-          <a:prstGeom prst="rect">
-            <a:avLst/>
-          </a:prstGeom>
-          <a:noFill/>
-        </p:spPr>
-        <p:txBody>
-          <a:bodyPr wrap="square" anchor="ctr">
-            <a:noAutofit/>
-          </a:bodyPr>
-          <a:lstStyle/>
-          <a:p>
-            <a:pPr algn="l"/>
-            <a:r>
-              <a:rPr sz="800" b="1" i="0">
-                <a:solidFill>
-                  <a:srgbClr val="003A59"/>
-                </a:solidFill>
-                <a:latin typeface="Poppins"/>
-              </a:rPr>
-              <a:t>Follow-up time</a:t>
-            </a:r>
-          </a:p>
-        </p:txBody>
-      </p:sp>
-      <p:sp>
-        <p:nvSpPr>
-          <p:cNvPr id="33" name="TextBox 32"/>
-          <p:cNvSpPr txBox="1"/>
-          <p:nvPr/>
-        </p:nvSpPr>
-        <p:spPr>
-          <a:xfrm>
-            <a:off x="5943600" y="1883664"/>
-            <a:ext cx="2926080" cy="265176"/>
-          </a:xfrm>
-          <a:prstGeom prst="rect">
-            <a:avLst/>
-          </a:prstGeom>
-          <a:noFill/>
-        </p:spPr>
-        <p:txBody>
-          <a:bodyPr wrap="square" anchor="ctr">
-            <a:noAutofit/>
-          </a:bodyPr>
-          <a:lstStyle/>
-          <a:p>
-            <a:pPr algn="l"/>
-            <a:r>
-              <a:rPr sz="800" b="0" i="0">
-                <a:solidFill>
-                  <a:srgbClr val="4A5C6B"/>
-                </a:solidFill>
-                <a:latin typeface="Poppins"/>
-              </a:rPr>
-              <a:t>AI staff and a monthly custom automation take it on</a:t>
-            </a:r>
-          </a:p>
-        </p:txBody>
-      </p:sp>
-      <p:sp>
-        <p:nvSpPr>
-          <p:cNvPr id="34" name="Rectangle 33"/>
-          <p:cNvSpPr/>
-          <p:nvPr/>
-        </p:nvSpPr>
-        <p:spPr>
-          <a:xfrm>
-            <a:off x="4572000" y="2432304"/>
-            <a:ext cx="4297680" cy="265176"/>
-          </a:xfrm>
-          <a:prstGeom prst="rect">
-            <a:avLst/>
-          </a:prstGeom>
-          <a:solidFill>
-            <a:srgbClr val="EEF2F5"/>
-          </a:solidFill>
-          <a:ln>
-            <a:solidFill>
-              <a:srgbClr val="FFFFFF"/>
-            </a:solidFill>
-          </a:ln>
-        </p:spPr>
-        <p:style>
-          <a:lnRef idx="1">
-            <a:schemeClr val="accent1"/>
-          </a:lnRef>
-          <a:fillRef idx="3">
-            <a:schemeClr val="accent1"/>
-          </a:fillRef>
-          <a:effectRef idx="2">
-            <a:schemeClr val="accent1"/>
-          </a:effectRef>
-          <a:fontRef idx="minor">
-            <a:schemeClr val="lt1"/>
-          </a:fontRef>
-        </p:style>
-        <p:txBody>
-          <a:bodyPr rtlCol="0" anchor="ctr"/>
-          <a:lstStyle/>
-          <a:p>
-            <a:pPr algn="ctr"/>
-          </a:p>
-        </p:txBody>
-      </p:sp>
-      <p:sp>
-        <p:nvSpPr>
-          <p:cNvPr id="35" name="Rectangle 34"/>
-          <p:cNvSpPr/>
-          <p:nvPr/>
-        </p:nvSpPr>
-        <p:spPr>
-          <a:xfrm>
-            <a:off x="4700016" y="2514600"/>
-            <a:ext cx="91440" cy="91440"/>
-          </a:xfrm>
-          <a:prstGeom prst="rect">
-            <a:avLst/>
-          </a:prstGeom>
-          <a:solidFill>
-            <a:srgbClr val="0091C9"/>
-          </a:solidFill>
-          <a:ln>
-            <a:solidFill>
-              <a:srgbClr val="FFFFFF"/>
-            </a:solidFill>
-          </a:ln>
-        </p:spPr>
-        <p:style>
-          <a:lnRef idx="1">
-            <a:schemeClr val="accent1"/>
-          </a:lnRef>
-          <a:fillRef idx="3">
-            <a:schemeClr val="accent1"/>
-          </a:fillRef>
-          <a:effectRef idx="2">
-            <a:schemeClr val="accent1"/>
-          </a:effectRef>
-          <a:fontRef idx="minor">
-            <a:schemeClr val="lt1"/>
-          </a:fontRef>
-        </p:style>
-        <p:txBody>
-          <a:bodyPr rtlCol="0" anchor="ctr"/>
-          <a:lstStyle/>
-          <a:p>
-            <a:pPr algn="ctr"/>
-          </a:p>
-        </p:txBody>
-      </p:sp>
-      <p:sp>
-        <p:nvSpPr>
-          <p:cNvPr id="36" name="TextBox 35"/>
-          <p:cNvSpPr txBox="1"/>
-          <p:nvPr/>
-        </p:nvSpPr>
-        <p:spPr>
-          <a:xfrm>
-            <a:off x="4846320" y="2432304"/>
-            <a:ext cx="1143000" cy="265176"/>
-          </a:xfrm>
-          <a:prstGeom prst="rect">
-            <a:avLst/>
-          </a:prstGeom>
-          <a:noFill/>
-        </p:spPr>
-        <p:txBody>
-          <a:bodyPr wrap="square" anchor="ctr">
-            <a:noAutofit/>
-          </a:bodyPr>
-          <a:lstStyle/>
-          <a:p>
-            <a:pPr algn="l"/>
-            <a:r>
-              <a:rPr sz="800" b="1" i="0">
-                <a:solidFill>
-                  <a:srgbClr val="003A59"/>
-                </a:solidFill>
-                <a:latin typeface="Poppins"/>
-              </a:rPr>
-              <a:t>No idle payroll</a:t>
-            </a:r>
-          </a:p>
-        </p:txBody>
-      </p:sp>
-      <p:sp>
-        <p:nvSpPr>
-          <p:cNvPr id="37" name="TextBox 36"/>
-          <p:cNvSpPr txBox="1"/>
-          <p:nvPr/>
-        </p:nvSpPr>
-        <p:spPr>
-          <a:xfrm>
-            <a:off x="5943600" y="2432304"/>
-            <a:ext cx="2926080" cy="265176"/>
-          </a:xfrm>
-          <a:prstGeom prst="rect">
-            <a:avLst/>
-          </a:prstGeom>
-          <a:noFill/>
-        </p:spPr>
-        <p:txBody>
-          <a:bodyPr wrap="square" anchor="ctr">
-            <a:noAutofit/>
-          </a:bodyPr>
-          <a:lstStyle/>
-          <a:p>
-            <a:pPr algn="l"/>
-            <a:r>
-              <a:rPr sz="800" b="0" i="0">
-                <a:solidFill>
-                  <a:srgbClr val="4A5C6B"/>
-                </a:solidFill>
-                <a:latin typeface="Poppins"/>
-              </a:rPr>
-              <a:t>AI Workforce Pro seats add capacity, not salary</a:t>
-            </a:r>
-          </a:p>
-        </p:txBody>
-      </p:sp>
-      <p:sp>
-        <p:nvSpPr>
-          <p:cNvPr id="38" name="Rectangle 37"/>
-          <p:cNvSpPr/>
-          <p:nvPr/>
-        </p:nvSpPr>
-        <p:spPr>
-          <a:xfrm>
-            <a:off x="0" y="4261104"/>
-            <a:ext cx="9144000" cy="557784"/>
-          </a:xfrm>
-          <a:prstGeom prst="rect">
-            <a:avLst/>
-          </a:prstGeom>
-          <a:solidFill>
-            <a:srgbClr val="002A41"/>
-          </a:solidFill>
-          <a:ln>
-            <a:solidFill>
-              <a:srgbClr val="FFFFFF"/>
-            </a:solidFill>
-          </a:ln>
-        </p:spPr>
-        <p:style>
-          <a:lnRef idx="1">
-            <a:schemeClr val="accent1"/>
-          </a:lnRef>
-          <a:fillRef idx="3">
-            <a:schemeClr val="accent1"/>
-          </a:fillRef>
-          <a:effectRef idx="2">
-            <a:schemeClr val="accent1"/>
-          </a:effectRef>
-          <a:fontRef idx="minor">
-            <a:schemeClr val="lt1"/>
-          </a:fontRef>
-        </p:style>
-        <p:txBody>
-          <a:bodyPr rtlCol="0" anchor="ctr"/>
-          <a:lstStyle/>
-          <a:p>
-            <a:pPr algn="ctr"/>
-          </a:p>
-        </p:txBody>
-      </p:sp>
-      <p:sp>
-        <p:nvSpPr>
-          <p:cNvPr id="39" name="Rectangle 38"/>
-          <p:cNvSpPr/>
-          <p:nvPr/>
-        </p:nvSpPr>
-        <p:spPr>
-          <a:xfrm>
-            <a:off x="0" y="4261104"/>
-            <a:ext cx="9144000" cy="18288"/>
-          </a:xfrm>
-          <a:prstGeom prst="rect">
-            <a:avLst/>
-          </a:prstGeom>
-          <a:solidFill>
-            <a:srgbClr val="69CD2B"/>
-          </a:solidFill>
-          <a:ln>
-            <a:solidFill>
-              <a:srgbClr val="FFFFFF"/>
-            </a:solidFill>
-          </a:ln>
-        </p:spPr>
-        <p:style>
-          <a:lnRef idx="1">
-            <a:schemeClr val="accent1"/>
-          </a:lnRef>
-          <a:fillRef idx="3">
-            <a:schemeClr val="accent1"/>
-          </a:fillRef>
-          <a:effectRef idx="2">
-            <a:schemeClr val="accent1"/>
-          </a:effectRef>
-          <a:fontRef idx="minor">
-            <a:schemeClr val="lt1"/>
-          </a:fontRef>
-        </p:style>
-        <p:txBody>
-          <a:bodyPr rtlCol="0" anchor="ctr"/>
-          <a:lstStyle/>
-          <a:p>
-            <a:pPr algn="ctr"/>
-          </a:p>
-        </p:txBody>
-      </p:sp>
-      <p:sp>
-        <p:nvSpPr>
-          <p:cNvPr id="40" name="TextBox 39"/>
-          <p:cNvSpPr txBox="1"/>
-          <p:nvPr/>
-        </p:nvSpPr>
-        <p:spPr>
-          <a:xfrm>
-            <a:off x="640080" y="4297680"/>
-            <a:ext cx="7863840" cy="493776"/>
-          </a:xfrm>
-          <a:prstGeom prst="rect">
-            <a:avLst/>
-          </a:prstGeom>
-          <a:noFill/>
-        </p:spPr>
-        <p:txBody>
-          <a:bodyPr wrap="square" anchor="ctr">
-            <a:noAutofit/>
-          </a:bodyPr>
-          <a:lstStyle/>
-          <a:p>
-            <a:pPr algn="ctr"/>
-            <a:r>
-              <a:rPr sz="950" b="0" i="0">
-                <a:solidFill>
-                  <a:srgbClr val="C2D8E6"/>
-                </a:solidFill>
-                <a:latin typeface="Poppins"/>
-              </a:rPr>
-              <a:t>"Someone just comes in and says, bam, this is working for you, let's go — and I get back to the legal work only I can do."</a:t>
-            </a:r>
-          </a:p>
-        </p:txBody>
-      </p:sp>
-      <p:sp>
-        <p:nvSpPr>
-          <p:cNvPr id="41" name="Rectangle 40"/>
-          <p:cNvSpPr/>
-          <p:nvPr/>
-        </p:nvSpPr>
-        <p:spPr>
-          <a:xfrm>
-            <a:off x="0" y="4818888"/>
-            <a:ext cx="9144000" cy="320040"/>
-          </a:xfrm>
-          <a:prstGeom prst="rect">
-            <a:avLst/>
-          </a:prstGeom>
-          <a:solidFill>
-            <a:srgbClr val="003A59"/>
-          </a:solidFill>
-          <a:ln>
-            <a:solidFill>
-              <a:srgbClr val="FFFFFF"/>
-            </a:solidFill>
-          </a:ln>
-        </p:spPr>
-        <p:style>
-          <a:lnRef idx="1">
-            <a:schemeClr val="accent1"/>
-          </a:lnRef>
-          <a:fillRef idx="3">
-            <a:schemeClr val="accent1"/>
-          </a:fillRef>
-          <a:effectRef idx="2">
-            <a:schemeClr val="accent1"/>
-          </a:effectRef>
-          <a:fontRef idx="minor">
-            <a:schemeClr val="lt1"/>
-          </a:fontRef>
-        </p:style>
-        <p:txBody>
-          <a:bodyPr rtlCol="0" anchor="ctr"/>
-          <a:lstStyle/>
-          <a:p>
-            <a:pPr algn="ctr"/>
-          </a:p>
-        </p:txBody>
-      </p:sp>
       <p:pic>
         <p:nvPicPr>
-          <p:cNvPr id="42" name="Picture 41" descr="smb_team_logo.png"/>
+          <p:cNvPr id="35" name="Picture 34" descr="smb_team_logo.png"/>
           <p:cNvPicPr>
             <a:picLocks noChangeAspect="1"/>
           </p:cNvPicPr>
@@ -7634,7 +7369,7 @@
       </p:pic>
       <p:sp>
         <p:nvSpPr>
-          <p:cNvPr id="43" name="TextBox 42"/>
+          <p:cNvPr id="36" name="TextBox 35"/>
           <p:cNvSpPr txBox="1"/>
           <p:nvPr/>
         </p:nvSpPr>
@@ -7669,7 +7404,7 @@
       </p:sp>
       <p:sp>
         <p:nvSpPr>
-          <p:cNvPr id="44" name="TextBox 43"/>
+          <p:cNvPr id="37" name="TextBox 36"/>
           <p:cNvSpPr txBox="1"/>
           <p:nvPr/>
         </p:nvSpPr>

</xml_diff>